<commit_message>
fix(mobile): perbaikan tata letak smartphone agar rapi & integrasi logo resmi UINSSC
</commit_message>
<xml_diff>
--- a/Ahli_Waris_Laki_Laki_dan_Perempuan.pptx
+++ b/Ahli_Waris_Laki_Laki_dan_Perempuan.pptx
@@ -3188,16 +3188,40 @@
           </a:p>
         </p:txBody>
       </p:sp>
-      <p:sp>
-        <p:nvSpPr>
-          <p:cNvPr id="4" name="TextBox 3"/>
+      <p:pic>
+        <p:nvPicPr>
+          <p:cNvPr id="4" name="Picture 3" descr="logo-uinssc.png"/>
+          <p:cNvPicPr>
+            <a:picLocks noChangeAspect="1"/>
+          </p:cNvPicPr>
+          <p:nvPr/>
+        </p:nvPicPr>
+        <p:blipFill>
+          <a:blip r:embed="rId2"/>
+          <a:stretch>
+            <a:fillRect/>
+          </a:stretch>
+        </p:blipFill>
+        <p:spPr>
+          <a:xfrm>
+            <a:off x="5577840" y="685800"/>
+            <a:ext cx="773668" cy="868680"/>
+          </a:xfrm>
+          <a:prstGeom prst="rect">
+            <a:avLst/>
+          </a:prstGeom>
+        </p:spPr>
+      </p:pic>
+      <p:sp>
+        <p:nvSpPr>
+          <p:cNvPr id="5" name="TextBox 4"/>
           <p:cNvSpPr txBox="1"/>
           <p:nvPr/>
         </p:nvSpPr>
         <p:spPr>
           <a:xfrm>
-            <a:off x="1097280" y="822960"/>
-            <a:ext cx="9966960" cy="2926080"/>
+            <a:off x="1097280" y="1645920"/>
+            <a:ext cx="9966960" cy="2194560"/>
           </a:xfrm>
           <a:prstGeom prst="rect">
             <a:avLst/>
@@ -3211,7 +3235,7 @@
           <a:lstStyle/>
           <a:p>
             <a:pPr algn="ctr">
-              <a:defRPr sz="2600">
+              <a:defRPr sz="2400">
                 <a:solidFill>
                   <a:srgbClr val="E6CA65"/>
                 </a:solidFill>
@@ -3249,7 +3273,7 @@
       </p:sp>
       <p:sp>
         <p:nvSpPr>
-          <p:cNvPr id="5" name="Rectangle 4"/>
+          <p:cNvPr id="6" name="Rectangle 5"/>
           <p:cNvSpPr/>
           <p:nvPr/>
         </p:nvSpPr>
@@ -3294,7 +3318,7 @@
       </p:sp>
       <p:sp>
         <p:nvSpPr>
-          <p:cNvPr id="6" name="TextBox 5"/>
+          <p:cNvPr id="7" name="TextBox 6"/>
           <p:cNvSpPr txBox="1"/>
           <p:nvPr/>
         </p:nvSpPr>
@@ -4724,6 +4748,30 @@
           </a:p>
         </p:txBody>
       </p:sp>
+      <p:pic>
+        <p:nvPicPr>
+          <p:cNvPr id="5" name="Picture 4" descr="logo-uinssc.png"/>
+          <p:cNvPicPr>
+            <a:picLocks noChangeAspect="1"/>
+          </p:cNvPicPr>
+          <p:nvPr/>
+        </p:nvPicPr>
+        <p:blipFill>
+          <a:blip r:embed="rId2"/>
+          <a:stretch>
+            <a:fillRect/>
+          </a:stretch>
+        </p:blipFill>
+        <p:spPr>
+          <a:xfrm>
+            <a:off x="5577840" y="3474720"/>
+            <a:ext cx="692229" cy="777240"/>
+          </a:xfrm>
+          <a:prstGeom prst="rect">
+            <a:avLst/>
+          </a:prstGeom>
+        </p:spPr>
+      </p:pic>
     </p:spTree>
   </p:cSld>
   <p:clrMapOvr>

</xml_diff>